<commit_message>
Versao completa do roteiro: so fala, com a origem de cada numero
A versao anterior deste segundo arquivo trazia orientacoes ao apresentador,
que nao era o pedido. Agora sao 11 blocos de texto corrido, escritos para
serem ditos, sem nenhuma instrucao.

A diferenca para o arquivo curto e que este abre as contas em voz alta:
o ticket de R$ 1.920 decomposto em 1.150 de aereo, 570 de hotel e 200 de
traslado; os 180 de economia como 2.200 menos 1.920 menos os 100 da taxa;
os 6,4% como media ponderada de 4% no aereo e 10% em hotel e traslado; os
42.000 alunos como 1,4 milhao vezes 12% vezes 25%; as 5.508 viagens como
alunos ativos por trimestre vezes 1,8; os 518 mil de volume aereo como 450
viagens a 1.150.

Duracao: 3.161 palavras, cerca de 24 minutos falados. Nao cabe nos 10
minutos do Squeeze - o arquivo curto continua sendo o de apresentar. Este
serve para ensaiar e para sustentar a arguicao.

Co-Authored-By: Claude Opus 5 <noreply@anthropic.com>
</commit_message>
<xml_diff>
--- a/sprints/sprint-04/entregaveis/Sprint_04_Kairos_Antevia_Notas_Detalhadas.pptx
+++ b/sprints/sprint-04/entregaveis/Sprint_04_Kairos_Antevia_Notas_Detalhadas.pptx
@@ -512,76 +512,25 @@
           <a:lstStyle/>
           <a:p>
             <a:r>
-              <a:t>A capa traz dois números, e é bom você saber de onde vêm antes de abrir a boca.</a:t>
+              <a:t>Boa apresentação a todos. Nós somos o Grupo Kairós e viemos apresentar a viabilidade econômica da Antévia ao longo de doze trimestres, estruturada em três cenários.</a:t>
             </a:r>
           </a:p>
           <a:p/>
           <a:p>
             <a:r>
-              <a:t>R$ 1,10 milhão é a soma dos doze trimestres do cenário tendencial. Não é faturamento</a:t>
-            </a:r>
-          </a:p>
-          <a:p>
-            <a:r>
-              <a:t>bruto: é o que fica com a Antévia, porque nós não compramos e revendemos passagem —</a:t>
-            </a:r>
-          </a:p>
-          <a:p>
-            <a:r>
-              <a:t>o aluno paga o fornecedor e nós intermediamos. O dinheiro que passa pelas mãos dele</a:t>
-            </a:r>
-          </a:p>
-          <a:p>
-            <a:r>
-              <a:t>é bem maior, R$ 9,61 milhões, e isso aparece mais adiante.</a:t>
+              <a:t>O número de topo é 1,10 milhão de reais de receita acumulada em três anos. Vale dizer desde já o que esse número é: ele é o que fica com a Antévia, e não o valor total que passa pelas mãos do aluno. Nós não compramos e revendemos passagem, nós intermediamos. O volume que circula é bem maior, 9,61 milhões, mas a nossa receita é a taxa de serviço somada à comissão dos fornecedores.</a:t>
             </a:r>
           </a:p>
           <a:p/>
           <a:p>
             <a:r>
-              <a:t>R$ 71 mil é só o ano um, ou seja, os quatro primeiros trimestres. É 6% do total de</a:t>
-            </a:r>
-          </a:p>
-          <a:p>
-            <a:r>
-              <a:t>três anos. Essa desproporção não é acidente nem erro de projeção: é a descrição de um</a:t>
-            </a:r>
-          </a:p>
-          <a:p>
-            <a:r>
-              <a:t>negócio que precisa de volume para ter margem e não tem volume no começo. É a tese da</a:t>
-            </a:r>
-          </a:p>
-          <a:p>
-            <a:r>
-              <a:t>apresentação inteira.</a:t>
+              <a:t>O foco da nossa atenção hoje, no entanto, não é o 1,10 milhão. É o primeiro ano, que gera 71 mil reais — apenas 6% do total de três anos. Essa desproporção não é um erro de projeção nem falta de ambição. É a descrição correta de um negócio que precisa de volume para ter margem e que não tem volume no começo. É essa a tese que vamos defender.</a:t>
             </a:r>
           </a:p>
           <a:p/>
           <a:p>
             <a:r>
-              <a:t>Ao abrir, não leia a capa. Diga que vocês vieram falar de viabilidade, que o número</a:t>
-            </a:r>
-          </a:p>
-          <a:p>
-            <a:r>
-              <a:t>de três anos é 1,10 milhão, e que o assunto real de hoje é o primeiro ano.</a:t>
-            </a:r>
-          </a:p>
-          <a:p/>
-          <a:p>
-            <a:r>
-              <a:t>E avise logo que esta sprint trata só de receita. Se vier pergunta sobre margem ou</a:t>
-            </a:r>
-          </a:p>
-          <a:p>
-            <a:r>
-              <a:t>lucro, a resposta honesta é que custos e investimentos são a Sprint 5 — não é fuga,</a:t>
-            </a:r>
-          </a:p>
-          <a:p>
-            <a:r>
-              <a:t>é o recorte que o Encontro 5 pediu.</a:t>
+              <a:t>Por último, um recorte importante: esta sprint trata de receita. Custos, despesas e investimentos são matéria da Sprint 5.</a:t>
             </a:r>
           </a:p>
         </p:txBody>
@@ -651,119 +600,37 @@
           <a:lstStyle/>
           <a:p>
             <a:r>
-              <a:t>Um gráfico de três barras. Ele é simples, e o valor dele não está nos números — está no</a:t>
-            </a:r>
-          </a:p>
-          <a:p>
-            <a:r>
-              <a:t>que sumiu dele.</a:t>
+              <a:t>Nesta análise nós movemos uma variável de cada vez, mantendo as outras no cenário tendencial. A base é 1,10 milhão de reais em três anos.</a:t>
             </a:r>
           </a:p>
           <a:p/>
           <a:p>
             <a:r>
-              <a:t>As barras mostram o que acontece com a receita de três anos quando você mexe numa variável</a:t>
-            </a:r>
-          </a:p>
-          <a:p>
-            <a:r>
-              <a:t>de cada vez, mantendo as outras no cenário tendencial. A base é R$ 1,10 milhão.</a:t>
+              <a:t>A primeira variável é a captação de alunos. Movendo 30 por cento para baixo ou para cima, a receita se move 30 por cento também. É proporcional, porque tudo no modelo é multiplicado pelo número de alunos, e é a variável dominante.</a:t>
             </a:r>
           </a:p>
           <a:p/>
           <a:p>
             <a:r>
-              <a:t>Alunos captados por ano, mais ou menos 30%: a receita varia mais ou menos 30% também. É</a:t>
-            </a:r>
-          </a:p>
-          <a:p>
-            <a:r>
-              <a:t>proporcional, porque tudo no modelo é multiplicado pelo número de alunos. É a barra</a:t>
-            </a:r>
-          </a:p>
-          <a:p>
-            <a:r>
-              <a:t>dominante.</a:t>
+              <a:t>A segunda é a taxa de serviço. Variando de 50 a 150 reais, a receita se move 25 por cento. É menos do que a captação, apesar de a taxa representar mais da metade da receita por viagem, porque a comissão não se mexe junto com ela.</a:t>
             </a:r>
           </a:p>
           <a:p/>
           <a:p>
             <a:r>
-              <a:t>Taxa de serviço, de R$ 50 a R$ 150: varia 25%. Repare que é menos que a captação, apesar de</a:t>
-            </a:r>
-          </a:p>
-          <a:p>
-            <a:r>
-              <a:t>a taxa ser mais da metade da receita por viagem — isso porque a comissão não se mexe junto.</a:t>
+              <a:t>A terceira é a comissão. Uma faixa abaixo ou acima produz de menos 15 a mais 29 por cento. É assimétrica porque o espaço para cair é menor do que o espaço para subir.</a:t>
             </a:r>
           </a:p>
           <a:p/>
           <a:p>
             <a:r>
-              <a:t>Comissão, uma faixa acima ou abaixo: de menos 15% a mais 29%. É assimétrica porque o espaço</a:t>
-            </a:r>
-          </a:p>
-          <a:p>
-            <a:r>
-              <a:t>para cair é menor que o espaço para subir.</a:t>
+              <a:t>Mas o que mais importa neste slide não é o gráfico. É o que sumiu dele. As versões anteriores deste modelo tinham cinco variáveis, e duas delas eram frágeis: o tamanho da turma e a taxa de adesão dentro da turma. Nenhuma das duas tinha validação, e as duas mexiam muito no resultado. Quando nós passamos a contar aluno captado, essas duas simplesmente deixaram de existir — não porque as resolvemos, mas porque a pergunta desapareceu.</a:t>
             </a:r>
           </a:p>
           <a:p/>
           <a:p>
             <a:r>
-              <a:t>Agora o ponto que interessa de verdade, e que está na faixa escura. As versões anteriores</a:t>
-            </a:r>
-          </a:p>
-          <a:p>
-            <a:r>
-              <a:t>deste modelo tinham cinco variáveis, e duas delas eram frágeis: o tamanho da turma e a taxa</a:t>
-            </a:r>
-          </a:p>
-          <a:p>
-            <a:r>
-              <a:t>de adesão dentro da turma. Nenhuma das duas tinha validação, e as duas mexiam muito no</a:t>
-            </a:r>
-          </a:p>
-          <a:p>
-            <a:r>
-              <a:t>resultado. Quando passamos a contar aluno captado direto, as duas simplesmente saíram —</a:t>
-            </a:r>
-          </a:p>
-          <a:p>
-            <a:r>
-              <a:t>não porque a gente resolveu, mas porque a pergunta deixou de existir.</a:t>
-            </a:r>
-          </a:p>
-          <a:p/>
-          <a:p>
-            <a:r>
-              <a:t>Sobraram três variáveis, todas explicáveis numa frase. E a dominante é a captação, que é</a:t>
-            </a:r>
-          </a:p>
-          <a:p>
-            <a:r>
-              <a:t>justamente a que está sob o nosso controle comercial. Um modelo cuja maior incerteza é o</a:t>
-            </a:r>
-          </a:p>
-          <a:p>
-            <a:r>
-              <a:t>próprio esforço de vendas é mais defensável que um cujo destino depende de uma premissa</a:t>
-            </a:r>
-          </a:p>
-          <a:p>
-            <a:r>
-              <a:t>que ninguém verificou.</a:t>
-            </a:r>
-          </a:p>
-          <a:p/>
-          <a:p>
-            <a:r>
-              <a:t>Se perguntarem por que a adesão sumiu: porque ela estava embutida numa conta desnecessária.</a:t>
-            </a:r>
-          </a:p>
-          <a:p>
-            <a:r>
-              <a:t>Se eu conto o aluno que aderiu, não preciso estimar quantos por cento da turma aderem.</a:t>
+              <a:t>Sobraram três variáveis, todas explicáveis em uma frase. E a dominante é a captação, que é justamente a que está sob o nosso controle comercial direto. Um modelo cuja maior incerteza é o próprio esforço de vendas é mais defensável do que um modelo cujo destino depende de uma premissa que ninguém verificou.</a:t>
             </a:r>
           </a:p>
         </p:txBody>
@@ -833,98 +700,31 @@
           <a:lstStyle/>
           <a:p>
             <a:r>
-              <a:t>O fechamento tem quatro números pequenos e uma mensagem grande. Não se perca nos números.</a:t>
+              <a:t>Para fechar, os números de três anos no cenário tendencial: 5.508 viagens organizadas, 1,95 milhão de reais devolvidos aos alunos em economia, 650 alunos ativos no último trimestre e 6,2 por cento do mercado onde podemos atuar.</a:t>
             </a:r>
           </a:p>
           <a:p/>
           <a:p>
             <a:r>
-              <a:t>Os quatro quadros: 5.508 viagens em três anos, que é a soma dos alunos ativos por trimestre</a:t>
-            </a:r>
-          </a:p>
-          <a:p>
-            <a:r>
-              <a:t>multiplicada por 1,8. R$ 1,95 milhão devolvidos aos alunos em economia. 650 alunos ativos no</a:t>
-            </a:r>
-          </a:p>
-          <a:p>
-            <a:r>
-              <a:t>último trimestre. E 6,2% do mercado onde atuamos.</a:t>
+              <a:t>Mas o número que realmente importa é outro. O ano 1 gera 71 mil reais de receita, o que dividido por doze meses dá menos de 6 mil reais por mês. Isso não sustenta uma equipe. Ou os sócios operam a coisa com as próprias mãos, ou é preciso capital para atravessar esse período. Nós não estamos escondendo isso, e a Sprint 5 é exatamente onde vamos dizer quanto custa atravessá-lo.</a:t>
             </a:r>
           </a:p>
           <a:p/>
           <a:p>
             <a:r>
-              <a:t>O número que importa é o outro: R$ 71 mil no ano um. Divididos por doze meses, dá menos de</a:t>
-            </a:r>
-          </a:p>
-          <a:p>
-            <a:r>
-              <a:t>R$ 6 mil por mês. Diga isso com todas as letras — não paga uma equipe. Ou os sócios operam</a:t>
-            </a:r>
-          </a:p>
-          <a:p>
-            <a:r>
-              <a:t>com as próprias mãos, ou é preciso capital para atravessar.</a:t>
+              <a:t>Por isso a nossa mensagem central é que o primeiro ano não deve ser medido por faturamento. Ele existe para produzir três ativos: a prova de que a operação funciona, o volume acumulado que abre a próxima faixa de comissão, e a concentração de alunos por campus, que é o que liga a tarifa de grupo. São três ativos, e não três reais.</a:t>
             </a:r>
           </a:p>
           <a:p/>
           <a:p>
             <a:r>
-              <a:t>Assumir isso é o que diferencia esta apresentação de uma que só mostra números crescendo.</a:t>
-            </a:r>
-          </a:p>
-          <a:p>
-            <a:r>
-              <a:t>E complete que a Sprint 5 é justamente onde vamos dizer quanto custa esse período.</a:t>
+              <a:t>A métrica do primeiro ano é quantos alunos nós captamos e onde eles estão. O faturamento vem depois.</a:t>
             </a:r>
           </a:p>
           <a:p/>
           <a:p>
             <a:r>
-              <a:t>A virada final é a mensagem que deve ficar depois que você calar. O ano um não deveria ser</a:t>
-            </a:r>
-          </a:p>
-          <a:p>
-            <a:r>
-              <a:t>medido por faturamento. Ele existe para produzir três coisas: prova de que a operação</a:t>
-            </a:r>
-          </a:p>
-          <a:p>
-            <a:r>
-              <a:t>funciona, volume acumulado que abre a próxima faixa de comissão, e concentração de alunos</a:t>
-            </a:r>
-          </a:p>
-          <a:p>
-            <a:r>
-              <a:t>por campus, que é o que liga a tarifa de grupo. São três ativos, não três reais.</a:t>
-            </a:r>
-          </a:p>
-          <a:p/>
-          <a:p>
-            <a:r>
-              <a:t>Se der para dizer uma frase só no encerramento, que seja esta: a métrica do primeiro ano é</a:t>
-            </a:r>
-          </a:p>
-          <a:p>
-            <a:r>
-              <a:t>quantos alunos captamos e onde eles estão. O faturamento vem depois.</a:t>
-            </a:r>
-          </a:p>
-          <a:p/>
-          <a:p>
-            <a:r>
-              <a:t>Depois agradeça e abra para perguntas. Os slides que mais geram pergunta são o 3, o 4 e o 8</a:t>
-            </a:r>
-          </a:p>
-          <a:p>
-            <a:r>
-              <a:t>— deixe-os à mão para voltar. E se tiver a planilha aberta noutra janela, na aba Premissas,</a:t>
-            </a:r>
-          </a:p>
-          <a:p>
-            <a:r>
-              <a:t>você consegue mudar uma célula e recalcular os três cenários na frente da banca.</a:t>
+              <a:t>Obrigado. Estamos à disposição para as perguntas.</a:t>
             </a:r>
           </a:p>
         </p:txBody>
@@ -994,107 +794,31 @@
           <a:lstStyle/>
           <a:p>
             <a:r>
-              <a:t>Quatro números nos cartões. Vale entender cada um, porque três deles voltam depois.</a:t>
+              <a:t>A nossa meta para o primeiro ano é captar 100 alunos, somando todas as turmas e todas as instituições parceiras.</a:t>
             </a:r>
           </a:p>
           <a:p/>
           <a:p>
             <a:r>
-              <a:t>R$ 100 é a taxa por módulo. Ela não saiu de uma pesquisa de disposição a pagar: saiu</a:t>
-            </a:r>
-          </a:p>
-          <a:p>
-            <a:r>
-              <a:t>da hipótese H6 da Sprint 1, que estimava uma faixa de R$ 50 a 150. Cem é o meio da</a:t>
-            </a:r>
-          </a:p>
-          <a:p>
-            <a:r>
-              <a:t>faixa. O slide 6 mostra que essa hipótese ainda está em aberto.</a:t>
+              <a:t>Esse número tem uma história que vale contar. Ele veio do exemplo da Banca de Modelagem, que dizia "100 alunos, 12 encontros". Nós tínhamos lido aquilo como tamanho de turma, e estava errado — uma turma da Fundação Dom Cabral tem por volta de 40 alunos. Relendo como meta anual de captação, o número volta a fazer sentido, e a turma sai do modelo de vez. Com isso, deixamos de depender de duas premissas frágeis: o tamanho fechado de uma turma e a taxa de adesão dentro dela.</a:t>
             </a:r>
           </a:p>
           <a:p/>
           <a:p>
             <a:r>
-              <a:t>3% a 6,4% é a comissão média que os fornecedores nos pagam, e o intervalo existe</a:t>
-            </a:r>
-          </a:p>
-          <a:p>
-            <a:r>
-              <a:t>porque ela cresce com o volume. O slide seguinte explica exatamente por quê.</a:t>
+              <a:t>Cada aluno cursa 12 módulos ao longo de 20 meses. Isso dá 0,6 módulo por mês, ou 1,8 viagem por trimestre. Essa é a engrenagem de todo o modelo: qualquer número de viagens que aparecer daqui em diante é alunos ativos multiplicado por 1,8.</a:t>
             </a:r>
           </a:p>
           <a:p/>
           <a:p>
             <a:r>
-              <a:t>100 alunos é a meta de captação do ano um. É o número mais importante da apresentação</a:t>
-            </a:r>
-          </a:p>
-          <a:p>
-            <a:r>
-              <a:t>e vale contar a história dele: veio do exemplo da Banca de Modelagem, que dizia "100</a:t>
-            </a:r>
-          </a:p>
-          <a:p>
-            <a:r>
-              <a:t>alunos, 12 encontros". A gente tinha lido isso como tamanho de turma, e estava errado</a:t>
-            </a:r>
-          </a:p>
-          <a:p>
-            <a:r>
-              <a:t>— turma da FDC tem por volta de 40 alunos. Relendo como meta anual de captação, o</a:t>
-            </a:r>
-          </a:p>
-          <a:p>
-            <a:r>
-              <a:t>número volta a fazer sentido e a turma sai da conta de vez.</a:t>
+              <a:t>A receita vem de duas fontes. A primeira é uma taxa de 100 reais por módulo cursado, paga voluntariamente pelo aluno. Cem reais é o meio da faixa de 50 a 150 que a hipótese 6 da Sprint 1 estimou, e essa hipótese continua em aberto. A segunda fonte é uma comissão paga pelos fornecedores, que começa em 3% e evolui até 6,4%. Ela cresce com o volume, e o próximo slide explica exatamente por quê.</a:t>
             </a:r>
           </a:p>
           <a:p/>
           <a:p>
             <a:r>
-              <a:t>R$ 0 é o que a escola desembolsa. Essa é a pergunta mais provável deste slide, então</a:t>
-            </a:r>
-          </a:p>
-          <a:p>
-            <a:r>
-              <a:t>tenha a resposta pronta: a escola entra com o CNPJ, que é o que viabiliza tarifa de</a:t>
-            </a:r>
-          </a:p>
-          <a:p>
-            <a:r>
-              <a:t>grupo, com o acesso ao aluno na matrícula e com o calendário das datas. É decisão de</a:t>
-            </a:r>
-          </a:p>
-          <a:p>
-            <a:r>
-              <a:t>desenho, não esquecimento — se ela precisasse aprovar verba, a venda entraria numa</a:t>
-            </a:r>
-          </a:p>
-          <a:p>
-            <a:r>
-              <a:t>fila orçamentária e levaria um ano. Sem desembolso, quem decide é a coordenação.</a:t>
-            </a:r>
-          </a:p>
-          <a:p/>
-          <a:p>
-            <a:r>
-              <a:t>Há um número que não está no slide e que move tudo: cada aluno faz 12 módulos em 20</a:t>
-            </a:r>
-          </a:p>
-          <a:p>
-            <a:r>
-              <a:t>meses, o que dá 0,6 módulo por mês, ou 1,8 viagem por trimestre. Essa é a engrenagem</a:t>
-            </a:r>
-          </a:p>
-          <a:p>
-            <a:r>
-              <a:t>do modelo inteiro. Se alguém perguntar como se chega às 5.508 viagens lá na frente,</a:t>
-            </a:r>
-          </a:p>
-          <a:p>
-            <a:r>
-              <a:t>a resposta é sempre alunos ativos multiplicados por 1,8.</a:t>
+              <a:t>Para a escola, o custo é zero. Ela entra com três coisas que já tem: o CNPJ, que é o que viabiliza a tarifa de grupo; o acesso ao aluno no momento da matrícula; e o calendário com as datas dos módulos. Isso é uma decisão de desenho, não um esquecimento. Se a escola precisasse aprovar verba, a venda entraria numa fila orçamentária e levaria um ano. Sem desembolso, quem decide é a coordenação, e a decisão sai rápido.</a:t>
             </a:r>
           </a:p>
         </p:txBody>
@@ -1164,160 +888,55 @@
           <a:lstStyle/>
           <a:p>
             <a:r>
-              <a:t>Este é o slide que sustenta a credibilidade da apresentação, e a tabela merece ser</a:t>
-            </a:r>
-          </a:p>
-          <a:p>
-            <a:r>
-              <a:t>lida devagar, linha por linha.</a:t>
+              <a:t>Por que uma companhia aérea venderia mais barato para a Antévia do que vende direto para o aluno? No primeiro ano, com uma ou duas instituições e cem alunos, ela não venderia. A nossa primeira versão deste modelo assumia que sim, aplicando 6,4% de comissão já no primeiro trimestre, e isso não se sustentava.</a:t>
             </a:r>
           </a:p>
           <a:p/>
           <a:p>
             <a:r>
-              <a:t>Comece pela pergunta do título. Por que uma companhia aérea daria desconto para uma</a:t>
-            </a:r>
-          </a:p>
-          <a:p>
-            <a:r>
-              <a:t>empresa que acabou de nascer? Não daria. E vale admitir que a nossa primeira versão</a:t>
-            </a:r>
-          </a:p>
-          <a:p>
-            <a:r>
-              <a:t>deste modelo assumia que sim — aplicava 6,4% de comissão já no primeiro trimestre.</a:t>
-            </a:r>
-          </a:p>
-          <a:p>
-            <a:r>
-              <a:t>Admitir isso é o que dá peso ao resto.</a:t>
+              <a:t>Por isso o modelo passou a ter três fases de poder de negociação.</a:t>
             </a:r>
           </a:p>
           <a:p/>
           <a:p>
             <a:r>
-              <a:t>Agora a tabela. Linha do ano um: ticket de R$ 1.920, que é aéreo de R$ 1.150, hotel de</a:t>
-            </a:r>
-          </a:p>
-          <a:p>
-            <a:r>
-              <a:t>R$ 570 por duas diárias e traslado de R$ 200. Economia líquida de R$ 180, que é a conta</a:t>
-            </a:r>
-          </a:p>
-          <a:p>
-            <a:r>
-              <a:t>2.200 menos 1.920 menos os 100 da nossa taxa. Retorno de 1,8 vez, que é simplesmente</a:t>
-            </a:r>
-          </a:p>
-          <a:p>
-            <a:r>
-              <a:t>180 dividido por 100. Comissão de 3%, que sobre 1.920 dá R$ 57,60. E a receita por</a:t>
-            </a:r>
-          </a:p>
-          <a:p>
-            <a:r>
-              <a:t>viagem de R$ 157,60, que são os 100 da taxa mais os 57,60 da comissão.</a:t>
+              <a:t>No ano 1, o ticket logístico é de 1.920 reais: 1.150 de aéreo, 570 de hotel por duas diárias e 200 de traslado. A economia líquida para o aluno é de 180 reais, que é a conta de 2.200 menos 1.920, menos os 100 da nossa taxa. O retorno é de 1,8 vez, ou seja, 180 divididos por 100. A comissão é de 3%, que sobre 1.920 dá 57 reais e 60 centavos. E a nossa receita por viagem fica em 157 e 60: os 100 da taxa mais os 57 e 60 da comissão.</a:t>
             </a:r>
           </a:p>
           <a:p/>
           <a:p>
             <a:r>
-              <a:t>As outras duas linhas seguem a mesma lógica com ticket menor e comissão maior. No ano</a:t>
-            </a:r>
-          </a:p>
-          <a:p>
-            <a:r>
-              <a:t>três, 6,4% sobre R$ 1.700 dá R$ 108,80, e a receita por viagem chega a R$ 208,80.</a:t>
+              <a:t>No ano 2, com bloqueios pontuais nas rotas que concentram, o ticket cai para 1.800 e a comissão sobe para 5%. A economia líquida do aluno vai para 300 reais e a nossa receita por viagem, para 190.</a:t>
             </a:r>
           </a:p>
           <a:p/>
           <a:p>
             <a:r>
-              <a:t>O cartão da esquerda é o coração do slide. No ano um a economia não vem de negociação</a:t>
-            </a:r>
-          </a:p>
-          <a:p>
-            <a:r>
-              <a:t>nenhuma: vem de comprar aos 90 dias em vez de em cima da hora. Isso é a curva tarifária</a:t>
-            </a:r>
-          </a:p>
-          <a:p>
-            <a:r>
-              <a:t>pública, está disponível para qualquer um, é de graça. É o que torna o primeiro ano</a:t>
-            </a:r>
-          </a:p>
-          <a:p>
-            <a:r>
-              <a:t>possível sem poder de barganha — e também o que limita o que ele entrega.</a:t>
+              <a:t>No ano 3, com convênio próprio, o ticket é de 1.700 e a comissão de 6,4%, o que dá 108 e 80 de comissão e 208 e 80 de receita por viagem. A economia do aluno chega a 400 reais.</a:t>
             </a:r>
           </a:p>
           <a:p/>
           <a:p>
             <a:r>
-              <a:t>Se perguntarem de onde vêm os percentuais de comissão, você tem três camadas de</a:t>
-            </a:r>
-          </a:p>
-          <a:p>
-            <a:r>
-              <a:t>resposta, e provavelmente as três impressionam:</a:t>
+              <a:t>O que sustenta o primeiro ano é uma alavanca que não custa nada e não exige negociar com fornecedor nenhum: a antecipação. Comprar aos 90 dias em vez de em cima da hora já é mais barato na curva tarifária pública, que está disponível para qualquer um. É isso que torna o ano 1 possível sem poder de barganha, e é também o que limita o que ele entrega.</a:t>
             </a:r>
           </a:p>
           <a:p/>
           <a:p>
             <a:r>
-              <a:t>Primeira, a fonte. Vieram da entrevista com o Bruno Brant, sócio da Velt, na Sprint 1.</a:t>
-            </a:r>
-          </a:p>
-          <a:p>
-            <a:r>
-              <a:t>Ele deu as faixas praticadas no mercado: convênio de R$ 250 a 500 mil por ano rende de</a:t>
-            </a:r>
-          </a:p>
-          <a:p>
-            <a:r>
-              <a:t>3 a 5%; acima de R$ 1 milhão por ano, de 8 a 12%.</a:t>
+              <a:t>Esses percentuais de comissão não foram inventados. Eles vêm da entrevista com o Bruno Brant, sócio da Velt, na Sprint 1. Ele nos deu as faixas praticadas no mercado: um convênio de 250 a 500 mil reais por ano rende de 3 a 5 por cento; acima de 1 milhão por ano, de 8 a 12 por cento.</a:t>
             </a:r>
           </a:p>
           <a:p/>
           <a:p>
             <a:r>
-              <a:t>Segunda, o teste. A gente conferiu o nosso próprio volume contra essas faixas. No ano</a:t>
-            </a:r>
-          </a:p>
-          <a:p>
-            <a:r>
-              <a:t>um serão 450 viagens, e a R$ 1.150 de aéreo cada, isso dá R$ 518 mil movimentados —</a:t>
-            </a:r>
-          </a:p>
-          <a:p>
-            <a:r>
-              <a:t>exatamente na entrada da primeira faixa, o que sustenta os 3%. Nos anos dois e três o</a:t>
-            </a:r>
-          </a:p>
-          <a:p>
-            <a:r>
-              <a:t>volume passa de R$ 1 milhão, o que abriria de 8 a 12%, e mesmo assim usamos 5% e 6,4%.</a:t>
-            </a:r>
-          </a:p>
-          <a:p>
-            <a:r>
-              <a:t>Fomos conservadores de propósito.</a:t>
+              <a:t>E nós conferimos o nosso próprio volume contra essas faixas. No ano 1 serão 450 viagens, e a 1.150 reais de aéreo cada uma, isso dá 518 mil reais movimentados — exatamente na entrada da primeira faixa, o que sustenta os 3%. Nos anos 2 e 3 o volume passa de 1 milhão, o que abriria de 8 a 12 por cento, e mesmo assim nós usamos 5 e 6,4. A projeção é conservadora de propósito.</a:t>
             </a:r>
           </a:p>
           <a:p/>
           <a:p>
             <a:r>
-              <a:t>Terceira, a composição dos 6,4%. É média ponderada: aéreo remunera pouco, cerca de 4%;</a:t>
-            </a:r>
-          </a:p>
-          <a:p>
-            <a:r>
-              <a:t>hotelaria remunera bem, uns 10%; traslado, 10% também. Aplicado ao ticket de R$ 1.700</a:t>
-            </a:r>
-          </a:p>
-          <a:p>
-            <a:r>
-              <a:t>dá R$ 108,80, que são os tais 6,4%.</a:t>
+              <a:t>Os 6,4% do ano 3, aliás, são uma média ponderada: o aéreo remunera pouco, cerca de 4%; a hotelaria remunera bem, uns 10%; o traslado, também 10%. Aplicado ao ticket de 1.700 reais, isso dá os 108 e 80.</a:t>
             </a:r>
           </a:p>
         </p:txBody>
@@ -1387,134 +1006,37 @@
           <a:lstStyle/>
           <a:p>
             <a:r>
-              <a:t>Este slide responde uma objeção que ninguém fez ainda, mas que faria. E a tabela só</a:t>
-            </a:r>
-          </a:p>
-          <a:p>
-            <a:r>
-              <a:t>funciona se você explicar a lógica antes de mostrar os números.</a:t>
+              <a:t>Uma tarifa de grupo não é um desconto que se pede. É um produto que só existe quando há passageiros suficientes no mesmo voo, e o mercado trabalha com cerca de 10 pessoas na mesma rota. A pergunta certa, então, não é quantos alunos nós temos no total. É quantos conseguimos juntar no mesmo campus e na mesma data de módulo.</a:t>
             </a:r>
           </a:p>
           <a:p/>
           <a:p>
             <a:r>
-              <a:t>Explique primeiro: tarifa de grupo não é um desconto que se pede. É um produto que só</a:t>
-            </a:r>
-          </a:p>
-          <a:p>
-            <a:r>
-              <a:t>existe quando há passageiros suficientes no mesmo voo. O mercado trabalha com cerca de</a:t>
-            </a:r>
-          </a:p>
-          <a:p>
-            <a:r>
-              <a:t>dez pessoas na mesma rota. Então a pergunta certa não é quantos alunos temos no total,</a:t>
-            </a:r>
-          </a:p>
-          <a:p>
-            <a:r>
-              <a:t>é quantos conseguimos juntar no mesmo campus e na mesma data de módulo.</a:t>
+              <a:t>A tabela responde isso, e é uma divisão simples. As colunas são o número de cidades de origem dos alunos: quanto mais espalhados eles estiverem, menos gente sobra por rota.</a:t>
             </a:r>
           </a:p>
           <a:p/>
           <a:p>
             <a:r>
-              <a:t>A tabela é uma divisão simples, e vale dizer isso em voz alta enquanto lê. As colunas</a:t>
-            </a:r>
-          </a:p>
-          <a:p>
-            <a:r>
-              <a:t>são o número de cidades de origem dos alunos — quanto mais espalhados, menos gente por</a:t>
-            </a:r>
-          </a:p>
-          <a:p>
-            <a:r>
-              <a:t>rota.</a:t>
+              <a:t>Com 100 alunos concentrados e 6 origens principais, são 16,7 passageiros por rota. Forma grupo com folga. Com 50 alunos e as mesmas 6 origens, são 8,3 — não forma, a não ser que as origens sejam apenas 5. Com 25 alunos não forma em nenhuma configuração.</a:t>
             </a:r>
           </a:p>
           <a:p/>
           <a:p>
             <a:r>
-              <a:t>Cem alunos divididos por seis origens dá quase 17 passageiros por rota. Forma grupo.</a:t>
-            </a:r>
-          </a:p>
-          <a:p>
-            <a:r>
-              <a:t>Cinquenta alunos por seis origens dá 8,3. Não forma, a menos que sejam só cinco origens.</a:t>
-            </a:r>
-          </a:p>
-          <a:p>
-            <a:r>
-              <a:t>Vinte e cinco alunos não formam em nenhuma configuração.</a:t>
+              <a:t>E a última linha é a que fecha o argumento. Uma turma de 40 alunos, mesmo com metade dela viajando, são 20 pessoas; divididas por 5 origens, dão 4 passageiros por rota. Nenhuma turma isolada forma tarifa de grupo. Nenhuma.</a:t>
             </a:r>
           </a:p>
           <a:p/>
           <a:p>
             <a:r>
-              <a:t>A última linha é a que fecha o argumento: uma turma de 40 alunos com metade viajando são</a:t>
-            </a:r>
-          </a:p>
-          <a:p>
-            <a:r>
-              <a:t>20 pessoas, e divididas por cinco origens dão 4 por rota. Nenhuma turma sozinha forma</a:t>
-            </a:r>
-          </a:p>
-          <a:p>
-            <a:r>
-              <a:t>grupo. Nenhuma.</a:t>
+              <a:t>Por isso a unidade de negociação não pode ser a turma. Ela tem que ser o campus numa data, somando alunos de turmas diferentes que chegam no mesmo dia. O limiar prático fica entre 50 e 60 alunos concentrados, que é o resultado de 10 passageiros multiplicados por 5 ou 6 origens. A nossa meta de 100 alunos no ano 1 ultrapassa esse limiar, desde que a captação seja concentrada e não pulverizada entre vários campi.</a:t>
             </a:r>
           </a:p>
           <a:p/>
           <a:p>
             <a:r>
-              <a:t>Daí a conclusão do slide: a unidade de negociação não pode ser a turma, tem que ser o</a:t>
-            </a:r>
-          </a:p>
-          <a:p>
-            <a:r>
-              <a:t>campus numa data, somando alunos de turmas diferentes que chegam no mesmo dia. O limiar</a:t>
-            </a:r>
-          </a:p>
-          <a:p>
-            <a:r>
-              <a:t>prático fica entre 50 e 60 alunos concentrados, que é 10 passageiros vezes cinco ou seis</a:t>
-            </a:r>
-          </a:p>
-          <a:p>
-            <a:r>
-              <a:t>origens.</a:t>
-            </a:r>
-          </a:p>
-          <a:p/>
-          <a:p>
-            <a:r>
-              <a:t>Termine com o ponto que joga a favor: se quem junta o volume é a nossa plataforma, o</a:t>
-            </a:r>
-          </a:p>
-          <a:p>
-            <a:r>
-              <a:t>bloqueio é ativo nosso, não da escola. A gente deixa de depender do CNPJ emprestado.</a:t>
-            </a:r>
-          </a:p>
-          <a:p/>
-          <a:p>
-            <a:r>
-              <a:t>Se perguntarem se então não temos tarifa de grupo no ano um: temos, se concentrarmos.</a:t>
-            </a:r>
-          </a:p>
-          <a:p>
-            <a:r>
-              <a:t>A meta de 100 alunos passa do limiar com folga. O que não pode é a captação ser</a:t>
-            </a:r>
-          </a:p>
-          <a:p>
-            <a:r>
-              <a:t>pulverizada entre vários campi e datas. Por isso a métrica do primeiro ano não é só</a:t>
-            </a:r>
-          </a:p>
-          <a:p>
-            <a:r>
-              <a:t>quantos alunos, é onde eles estão.</a:t>
+              <a:t>Isso tem uma consequência que joga a favor do negócio: se quem agrega e gerencia esse volume é a nossa plataforma, o bloqueio é um ativo nosso, e não da escola. Nós deixamos de depender de um CNPJ emprestado.</a:t>
             </a:r>
           </a:p>
         </p:txBody>
@@ -1584,103 +1106,37 @@
           <a:lstStyle/>
           <a:p>
             <a:r>
-              <a:t>Uma tabela de sete linhas. Você não precisa ler todas — precisa saber ler três.</a:t>
+              <a:t>Hoje um aluno que mora fora desembolsa em média 2.200 reais por módulo comprando em cima da hora: 1.400 de aéreo, 600 de hotel por duas diárias e 200 de traslado. Esse é o ponto de partida contra o qual tudo aqui é medido.</a:t>
             </a:r>
           </a:p>
           <a:p/>
           <a:p>
             <a:r>
-              <a:t>A coluna "hoje" é o aluno que compra em cima da hora: R$ 1.400 de aéreo, R$ 600 de hotel</a:t>
-            </a:r>
-          </a:p>
-          <a:p>
-            <a:r>
-              <a:t>por duas diárias, R$ 200 de traslado. Total de R$ 2.200 por módulo. Esse é o ponto de</a:t>
-            </a:r>
-          </a:p>
-          <a:p>
-            <a:r>
-              <a:t>partida contra o qual tudo é medido.</a:t>
+              <a:t>Na fase 1, o subtotal logístico cai para 1.920 reais. A queda vem quase toda do aéreo, que sai de 1.400 para 1.150 só pela antecipação da compra. Somando a nossa taxa de 100 reais, o aluno desembolsa 2.020 e economiza 180 líquidos — uma redução de 8,2% no que sai do bolso dele.</a:t>
             </a:r>
           </a:p>
           <a:p/>
           <a:p>
             <a:r>
-              <a:t>A linha do subtotal logístico mostra a nossa entrega caindo fase a fase: 1.920, depois</a:t>
-            </a:r>
-          </a:p>
-          <a:p>
-            <a:r>
-              <a:t>1.800, depois 1.700. Só o aéreo explica a maior parte: 1.150 no ano um, 1.020 no ano</a:t>
-            </a:r>
-          </a:p>
-          <a:p>
-            <a:r>
-              <a:t>três.</a:t>
+              <a:t>Na fase 2 o subtotal vai para 1.800 e a economia líquida sobe para 300 reais, o que é uma redução de 13,6%.</a:t>
             </a:r>
           </a:p>
           <a:p/>
           <a:p>
             <a:r>
-              <a:t>A linha da economia líquida é a que importa para o aluno: R$ 180, R$ 300, R$ 400. A</a:t>
-            </a:r>
-          </a:p>
-          <a:p>
-            <a:r>
-              <a:t>conta é sempre a mesma — 2.200 menos o subtotal da fase, menos os R$ 100 da nossa taxa.</a:t>
+              <a:t>E na fase 3, com convênio próprio, o subtotal chega a 1.700 e a economia líquida a 400 reais, uma redução de 18,2%.</a:t>
             </a:r>
           </a:p>
           <a:p/>
           <a:p>
             <a:r>
-              <a:t>E a última linha, a redução no desembolso, é essa economia dividida pelos R$ 2.200</a:t>
-            </a:r>
-          </a:p>
-          <a:p>
-            <a:r>
-              <a:t>originais: 8,2%, 13,6%, 18,2%.</a:t>
+              <a:t>A meta que nós fixamos lá na Sprint 1 era reduzir de 15 a 25 por cento o custo do aluno. Nós entregamos 18,2% na fase 3, dentro da meta, mas só na fase 3. Preferimos mostrar assim, fase a fase, do que prometer o número cheio desde o primeiro dia.</a:t>
             </a:r>
           </a:p>
           <a:p/>
           <a:p>
             <a:r>
-              <a:t>Aqui vale um cuidado. A meta que o grupo fixou na Sprint 1 era reduzir de 15 a 25% o</a:t>
-            </a:r>
-          </a:p>
-          <a:p>
-            <a:r>
-              <a:t>custo do aluno, e o slide mostra que a gente só chega lá na fase três, com 18,2%. Se</a:t>
-            </a:r>
-          </a:p>
-          <a:p>
-            <a:r>
-              <a:t>você disser "de 15 a 25%" enquanto a tabela mostra 18,2%, alguém pode estranhar. É mais</a:t>
-            </a:r>
-          </a:p>
-          <a:p>
-            <a:r>
-              <a:t>seguro dizer o número exato e completar que ele está dentro da meta.</a:t>
-            </a:r>
-          </a:p>
-          <a:p/>
-          <a:p>
-            <a:r>
-              <a:t>Fecha com o ponto comercial, que é mais importante que a tabela: no primeiro ano o aluno</a:t>
-            </a:r>
-          </a:p>
-          <a:p>
-            <a:r>
-              <a:t>não compra pelo desconto, porque R$ 180 numa viagem de R$ 2.200 não muda a vida de</a:t>
-            </a:r>
-          </a:p>
-          <a:p>
-            <a:r>
-              <a:t>ninguém. Ele compra porque para de precisar orquestrar três plataformas a cada módulo.</a:t>
-            </a:r>
-          </a:p>
-          <a:p>
-            <a:r>
-              <a:t>O desconto vira argumento principal só quando o volume abre a tarifa de grupo.</a:t>
+              <a:t>E há um ponto comercial que é mais importante do que a tabela inteira: no primeiro ano o aluno não compra pelo desconto. Cento e oitenta reais numa viagem de 2.200 não muda a vida de ninguém. Ele compra porque deixa de precisar orquestrar três plataformas diferentes a cada módulo, e porque passa a saber, desde a matrícula, quanto o programa inteiro vai custar de deslocamento. O desconto só vira argumento principal quando o volume abre a tarifa de grupo.</a:t>
             </a:r>
           </a:p>
         </p:txBody>
@@ -1750,101 +1206,25 @@
           <a:lstStyle/>
           <a:p>
             <a:r>
-              <a:t>Este é o slide mais dispensável da apresentação. Se o tempo apertar, é ele que sai.</a:t>
-            </a:r>
-          </a:p>
-          <a:p>
-            <a:r>
-              <a:t>Mas se der tempo, ele responde a exigência de pesquisa de preços do Encontro 5.</a:t>
+              <a:t>Antes de definir o nosso preço, nós olhamos como o mercado cobra hoje. São cinco alternativas, e nenhuma delas resolve a operação inteira de um programa executivo.</a:t>
             </a:r>
           </a:p>
           <a:p/>
           <a:p>
             <a:r>
-              <a:t>Cinco alternativas, e a leitura é sempre a mesma: cada uma resolve um pedaço e nenhuma</a:t>
-            </a:r>
-          </a:p>
-          <a:p>
-            <a:r>
-              <a:t>resolve o programa inteiro.</a:t>
+              <a:t>Os aplicativos das próprias companhias não cobram taxa nenhuma, mas resolvem um trecho e não sabem que existe um calendário acadêmico. As OTAs, como Decolar e CVC, cobram de zero a 80 reais por emissão e trabalham viagem a viagem, sempre reagindo a uma busca do aluno. As agências tradicionais cobram de 40 a 120 reais por bilhete e só agem quando alguém pede cotação. As plataformas B2B, como Onfly e Argo, cobram de 20 a 60 reais por usuário por mês, mas exigem CNPJ — e é exatamente aí que o aluno pessoa física fica de fora. Foi essa lacuna que a Sprint 1 chamou de órfão estrutural. E os concierges premium cobram de 5 a 15 por cento do valor da viagem, mas não existe nenhum recorte para aluno-executivo.</a:t>
             </a:r>
           </a:p>
           <a:p/>
           <a:p>
             <a:r>
-              <a:t>Aplicativos das companhias não cobram taxa nenhuma, mas resolvem um trecho e não sabem</a:t>
-            </a:r>
-          </a:p>
-          <a:p>
-            <a:r>
-              <a:t>que existe um calendário acadêmico. As OTAs, Decolar e CVC, cobram de zero a R$ 80 por</a:t>
-            </a:r>
-          </a:p>
-          <a:p>
-            <a:r>
-              <a:t>emissão e trabalham viagem a viagem, sob demanda do aluno. Agência tradicional cobra de</a:t>
-            </a:r>
-          </a:p>
-          <a:p>
-            <a:r>
-              <a:t>R$ 40 a 120 por bilhete e só age quando alguém pede cotação. Plataformas B2B como Onfly</a:t>
-            </a:r>
-          </a:p>
-          <a:p>
-            <a:r>
-              <a:t>e Argo cobram de R$ 20 a 60 por usuário por mês, mas exigem CNPJ — e é exatamente aí que</a:t>
-            </a:r>
-          </a:p>
-          <a:p>
-            <a:r>
-              <a:t>o aluno pessoa física fica de fora. Foi essa lacuna que a Sprint 1 chamou de órfão</a:t>
-            </a:r>
-          </a:p>
-          <a:p>
-            <a:r>
-              <a:t>estrutural. E concierge premium cobra de 5 a 15% do valor da viagem, mas não existe</a:t>
-            </a:r>
-          </a:p>
-          <a:p>
-            <a:r>
-              <a:t>nenhum recorte para aluno-executivo.</a:t>
+              <a:t>A nossa taxa de 100 reais sobre um ticket de 1.920 representa 5,2 por cento. Ou seja, nós ficamos no piso da faixa de concierge premium e acima da agência tradicional. A diferença é que aqui o serviço cobre passagem, hotel, traslado e reembolso de todos os módulos do programa, e não uma viagem avulsa.</a:t>
             </a:r>
           </a:p>
           <a:p/>
           <a:p>
             <a:r>
-              <a:t>Note que a nossa taxa de R$ 100 sobre um ticket de R$ 1.920 dá 5,2%. Ou seja, estamos</a:t>
-            </a:r>
-          </a:p>
-          <a:p>
-            <a:r>
-              <a:t>no piso da faixa de concierge premium, e acima da agência tradicional. A diferença é que</a:t>
-            </a:r>
-          </a:p>
-          <a:p>
-            <a:r>
-              <a:t>aqui o serviço cobre passagem, hotel, traslado e reembolso de todos os módulos, não uma</a:t>
-            </a:r>
-          </a:p>
-          <a:p>
-            <a:r>
-              <a:t>viagem avulsa.</a:t>
-            </a:r>
-          </a:p>
-          <a:p/>
-          <a:p>
-            <a:r>
-              <a:t>A frase da faixa dourada é o achado do slide, e vale dizer com calma: o custo real da</a:t>
-            </a:r>
-          </a:p>
-          <a:p>
-            <a:r>
-              <a:t>decisão tardia é invisível para o aluno. Ele não paga uma taxa alta — ele paga uma</a:t>
-            </a:r>
-          </a:p>
-          <a:p>
-            <a:r>
-              <a:t>passagem cara. Por isso não percebe que está perdendo dinheiro.</a:t>
+              <a:t>O achado deste levantamento é o seguinte: o custo real da decisão tardia é invisível para o aluno. Ele não paga uma taxa alta — ele paga uma passagem cara. E por isso não percebe que está perdendo dinheiro.</a:t>
             </a:r>
           </a:p>
         </p:txBody>
@@ -1914,98 +1294,31 @@
           <a:lstStyle/>
           <a:p>
             <a:r>
-              <a:t>Quatro cartões, e os três primeiros são a mesma divisão feita três vezes.</a:t>
+              <a:t>A nossa taxa de 100 reais foi ancorada no valor que o serviço devolve ao aluno, e não em uma disposição arbitrária de pagamento.</a:t>
             </a:r>
           </a:p>
           <a:p/>
           <a:p>
             <a:r>
-              <a:t>1,8 vez é R$ 180 divididos por R$ 100. Ou seja: no ano um o aluno paga a nossa taxa e</a:t>
-            </a:r>
-          </a:p>
-          <a:p>
-            <a:r>
-              <a:t>recebe de volta quase o dobro dela em economia. É positivo, mas apertado.</a:t>
+              <a:t>No primeiro ano, o aluno paga 100 reais e recebe 180 líquidos de economia. É um retorno de 1,8 vez. No ano 2, com a economia em 300 reais, o retorno vai para 3 vezes. E no ano 3, com 400 reais de economia, chega a 4 vezes o valor investido.</a:t>
             </a:r>
           </a:p>
           <a:p/>
           <a:p>
             <a:r>
-              <a:t>3,0 vezes é R$ 300 por R$ 100, no ano dois. E 4,0 vezes é R$ 400 por R$ 100, no ano três.</a:t>
+              <a:t>Há um quarto número neste slide que é o mais interessante deles. Ele mostra o peso da nossa taxa dentro da receita por viagem. No ano 1, 100 reais de taxa dentro de 157 e 60 de receita total representam 63 por cento. No ano 3, os mesmos 100 reais dentro de 208 e 80 representam 48 por cento.</a:t>
             </a:r>
           </a:p>
           <a:p/>
           <a:p>
             <a:r>
-              <a:t>O quarto cartão é diferente e é o mais interessante. Ele mostra o peso da nossa taxa</a:t>
-            </a:r>
-          </a:p>
-          <a:p>
-            <a:r>
-              <a:t>dentro da receita por viagem. No ano um, R$ 100 de taxa dentro de R$ 157,60 de receita</a:t>
-            </a:r>
-          </a:p>
-          <a:p>
-            <a:r>
-              <a:t>total dá 63%. No ano três, R$ 100 dentro de R$ 208,80 dá 48%.</a:t>
+              <a:t>O que isso significa é que, conforme a comissão dos fornecedores cresce, nós ficamos menos dependentes do bolso do aluno. É uma redução de risco, e não apenas um número que melhora. E é o contrário do que acontece em muitos modelos, onde o cliente vai pagando mais à medida que o negócio cresce.</a:t>
             </a:r>
           </a:p>
           <a:p/>
           <a:p>
             <a:r>
-              <a:t>Explique o que isso significa: conforme a comissão dos fornecedores cresce, a gente fica</a:t>
-            </a:r>
-          </a:p>
-          <a:p>
-            <a:r>
-              <a:t>menos dependente do bolso do aluno. É uma redução de risco, não só um número bonito. E é</a:t>
-            </a:r>
-          </a:p>
-          <a:p>
-            <a:r>
-              <a:t>o contrário do que muita startup faz, que é aumentar o preço para o cliente à medida que</a:t>
-            </a:r>
-          </a:p>
-          <a:p>
-            <a:r>
-              <a:t>cresce.</a:t>
-            </a:r>
-          </a:p>
-          <a:p/>
-          <a:p>
-            <a:r>
-              <a:t>A faixa escura embaixo é a consequência comercial, e é o que você deve deixar no ar: no</a:t>
-            </a:r>
-          </a:p>
-          <a:p>
-            <a:r>
-              <a:t>primeiro ano a venda não se sustenta só no desconto, porque a folga é pequena. Ela se</a:t>
-            </a:r>
-          </a:p>
-          <a:p>
-            <a:r>
-              <a:t>sustenta no tempo devolvido ao aluno.</a:t>
-            </a:r>
-          </a:p>
-          <a:p/>
-          <a:p>
-            <a:r>
-              <a:t>Se perguntarem da H6, a hipótese de que o aluno pagaria de R$ 50 a 150: ela continua em</a:t>
-            </a:r>
-          </a:p>
-          <a:p>
-            <a:r>
-              <a:t>aberto. Os R$ 100 são o meio da faixa. Se a validação apontar R$ 50, o modelo perde</a:t>
-            </a:r>
-          </a:p>
-          <a:p>
-            <a:r>
-              <a:t>cerca de um quarto da receita de três anos — fica menor, não deixa de existir. E como o</a:t>
-            </a:r>
-          </a:p>
-          <a:p>
-            <a:r>
-              <a:t>peso da taxa cai com o tempo, o dano se concentra no ano um.</a:t>
+              <a:t>A consequência comercial disso é direta: no primeiro ano a venda não se sustenta apenas no desconto, porque a folga é pequena. Ela se sustenta no tempo devolvido ao aluno e na previsibilidade do custo. E se a hipótese 6 se confirmar no piso da faixa, com o aluno disposto a pagar apenas 50 reais, o modelo perde cerca de um quarto da receita de três anos. Fica menor, mas não deixa de existir.</a:t>
             </a:r>
           </a:p>
         </p:txBody>
@@ -2075,139 +1388,37 @@
           <a:lstStyle/>
           <a:p>
             <a:r>
-              <a:t>Este é o slide que mais gera dúvida, então vá devagar e explique a lógica do funil</a:t>
-            </a:r>
-          </a:p>
-          <a:p>
-            <a:r>
-              <a:t>antes de qualquer número. São três recortes, do maior para o menor, e cada faixa responde</a:t>
-            </a:r>
-          </a:p>
-          <a:p>
-            <a:r>
-              <a:t>uma pergunta diferente.</a:t>
+              <a:t>O nosso potencial de mercado foi construído de baixo para cima, e ele responde a três perguntas, do maior recorte para o menor.</a:t>
             </a:r>
           </a:p>
           <a:p/>
           <a:p>
             <a:r>
-              <a:t>Quantos existem. Partimos do dado do IBGE, 1,4 milhão de matriculados em pós-graduação</a:t>
-            </a:r>
-          </a:p>
-          <a:p>
-            <a:r>
-              <a:t>no Brasil. Desses, estimamos 12% em programas executivos presenciais e periódicos, e</a:t>
-            </a:r>
-          </a:p>
-          <a:p>
-            <a:r>
-              <a:t>desses, 25% que viajam de outra cidade para estudar. Isso dá 42 mil alunos-viajantes.</a:t>
-            </a:r>
-          </a:p>
-          <a:p>
-            <a:r>
-              <a:t>Cada um faz 7,2 viagens por ano, que é a conta de 12 módulos em 20 meses anualizada.</a:t>
-            </a:r>
-          </a:p>
-          <a:p>
-            <a:r>
-              <a:t>São 302 mil viagens por ano, e a R$ 208,80 de receita cada, dá os R$ 63,1 milhões.</a:t>
+              <a:t>A primeira pergunta é quantos existem. Nós partimos do dado do IBGE, de 1,4 milhão de matriculados em pós-graduação no Brasil. Desses, estimamos 12 por cento em programas executivos presenciais e periódicos, e desses, 25 por cento que viajam de outra cidade para estudar. Isso nos dá 42 mil alunos-viajantes. Cada um faz 7,2 viagens por ano, que é a conta de 12 módulos em 20 meses anualizada, o que resulta em 302 mil viagens por ano. A 208 e 80 de receita por viagem, o mercado total representa 63,1 milhões de reais por ano. Vale registrar que os dois filtros, os 12 e os 25 por cento, ainda são estimativas nossas e não foram validados.</a:t>
             </a:r>
           </a:p>
           <a:p/>
           <a:p>
             <a:r>
-              <a:t>Diga que os dois filtros, os 12% e os 25%, são estimativas nossas e ainda não foram</a:t>
-            </a:r>
-          </a:p>
-          <a:p>
-            <a:r>
-              <a:t>validados. Assumir isso na frente da banca é melhor do que ser perguntado.</a:t>
+              <a:t>A segunda pergunta é quantos podemos atender. A Sprint 1 nos mostrou uma coisa incômoda: a dor não é universal. As coordenadoras de Manaus e de Belém nos disseram que a maioria dos alunos delas é local e não sente esse problema. A dor se concentra nos campi que recebem aluno de fora — Nova Lima, São Paulo e Rio de Janeiro. Restringindo a esses polos, chegamos a 10.500 alunos e 15,8 milhões de reais por ano.</a:t>
             </a:r>
           </a:p>
           <a:p/>
           <a:p>
             <a:r>
-              <a:t>Quantos podemos atender. A Sprint 1 mostrou uma coisa incômoda: a dor não é universal.</a:t>
-            </a:r>
-          </a:p>
-          <a:p>
-            <a:r>
-              <a:t>As coordenadoras de Manaus e Belém disseram que a maioria dos alunos delas é local e não</a:t>
-            </a:r>
-          </a:p>
-          <a:p>
-            <a:r>
-              <a:t>sente o problema. A dor se concentra nos campi que recebem aluno de fora — Nova Lima, São</a:t>
-            </a:r>
-          </a:p>
-          <a:p>
-            <a:r>
-              <a:t>Paulo e Rio. Restringindo a esses polos, chegamos a 10.500 alunos e R$ 15,8 milhões por</a:t>
-            </a:r>
-          </a:p>
-          <a:p>
-            <a:r>
-              <a:t>ano.</a:t>
+              <a:t>A terceira pergunta é quantos vamos atender, e essa é a nossa meta: 650 alunos ativos no décimo segundo trimestre, o que anualizado representa 977 mil reais de receita, ou 6,2 por cento desses 10.500.</a:t>
             </a:r>
           </a:p>
           <a:p/>
           <a:p>
             <a:r>
-              <a:t>Quantos vamos atender. Esta é a nossa meta: 650 alunos ativos no décimo segundo trimestre,</a:t>
-            </a:r>
-          </a:p>
-          <a:p>
-            <a:r>
-              <a:t>o que anualizado dá R$ 977 mil de receita, ou 6,2% dos 10.500.</a:t>
+              <a:t>Um detalhe importante de leitura: os 650 são alunos ativos no último trimestre, e não a soma dos três anos. É a base de clientes que a operação tem funcionando ao final do ano 3.</a:t>
             </a:r>
           </a:p>
           <a:p/>
           <a:p>
             <a:r>
-              <a:t>Aqui tem uma armadilha de leitura que você precisa desarmar antes que alguém caia nela:</a:t>
-            </a:r>
-          </a:p>
-          <a:p>
-            <a:r>
-              <a:t>os 650 são alunos ATIVOS no último trimestre. Não é a soma dos três anos. É a base de</a:t>
-            </a:r>
-          </a:p>
-          <a:p>
-            <a:r>
-              <a:t>clientes que a operação tem funcionando ao fim do ano três.</a:t>
-            </a:r>
-          </a:p>
-          <a:p/>
-          <a:p>
-            <a:r>
-              <a:t>A tabela de baixo mostra a progressão: 100 alunos no ano um, que é 1% do mercado onde</a:t>
-            </a:r>
-          </a:p>
-          <a:p>
-            <a:r>
-              <a:t>atuamos; 280 no ano dois, 2,7%; 650 no ano três, 6,2%.</a:t>
-            </a:r>
-          </a:p>
-          <a:p/>
-          <a:p>
-            <a:r>
-              <a:t>Se alguém disser que 6,2% é pouco, a resposta é que é pouco e é proposital. A nossa</a:t>
-            </a:r>
-          </a:p>
-          <a:p>
-            <a:r>
-              <a:t>primeira versão projetava 24% do mesmo mercado em três anos, e aquilo não se defendia</a:t>
-            </a:r>
-          </a:p>
-          <a:p>
-            <a:r>
-              <a:t>para um negócio que capta aluno por aluno pelo canal da escola. Trocamos um número</a:t>
-            </a:r>
-          </a:p>
-          <a:p>
-            <a:r>
-              <a:t>bonito por um número sustentável.</a:t>
+              <a:t>A progressão é de 100 alunos no ano 1, que é 1 por cento desse mercado, para 280 no ano 2, com 2,7 por cento, chegando aos 650 e 6,2 por cento no ano 3. A nossa primeira versão projetava 24 por cento do mesmo mercado em três anos, e aquilo não se defendia para um negócio que capta aluno por aluno pelo canal da escola. Nós trocamos um número bonito por um número sustentável.</a:t>
             </a:r>
           </a:p>
         </p:txBody>
@@ -2277,124 +1488,37 @@
           <a:lstStyle/>
           <a:p>
             <a:r>
-              <a:t>Três cartões e uma tabela. O ponto que você tem que deixar claro logo no início é que</a:t>
-            </a:r>
-          </a:p>
-          <a:p>
-            <a:r>
-              <a:t>os três cenários mudam uma variável só: quantos alunos a operação capta. As três fases de</a:t>
-            </a:r>
-          </a:p>
-          <a:p>
-            <a:r>
-              <a:t>negociação são idênticas nos três. Isso é importante porque mostra que não estamos</a:t>
-            </a:r>
-          </a:p>
-          <a:p>
-            <a:r>
-              <a:t>inflando o cenário otimista com premissas otimistas empilhadas.</a:t>
+              <a:t>Nós trabalhamos com três cenários de receita ao longo de três anos, e o que separa um do outro é uma variável apenas: quantos alunos a operação consegue captar. As três fases de negociação são idênticas nos três cenários, o que significa que nós não empilhamos premissas otimistas no cenário otimista.</a:t>
             </a:r>
           </a:p>
           <a:p/>
           <a:p>
             <a:r>
-              <a:t>Cenário pessimista: 50 alunos captados no ano um, chegando a 320 ativos no fim do ano</a:t>
-            </a:r>
-          </a:p>
-          <a:p>
-            <a:r>
-              <a:t>três. Total de R$ 551 mil.</a:t>
+              <a:t>No cenário pessimista, captamos 50 alunos no ano 1 e chegamos a 320 ativos ao final do ano 3, totalizando 551 mil reais de receita.</a:t>
             </a:r>
           </a:p>
           <a:p/>
           <a:p>
             <a:r>
-              <a:t>Tendencial, que é a nossa diretriz: 100 alunos no ano um, 650 no ano três, R$ 1,10 milhão.</a:t>
+              <a:t>No cenário tendencial, que é a nossa diretriz, captamos 100 alunos no ano 1 e chegamos a 650 ativos, gerando 1,10 milhão de reais. Abrindo por ano: 71 mil no ano 1, 284 mil no ano 2 e 744 mil no ano 3. Essa curva é inclinada por dois motivos que se somam — o número de alunos cresce, e a receita por viagem também cresce, de 157 e 60 para 208 e 80, porque a comissão melhora.</a:t>
             </a:r>
           </a:p>
           <a:p/>
           <a:p>
             <a:r>
-              <a:t>Otimista: 160 no ano um, 1.100 no ano três, R$ 1,83 milhão.</a:t>
+              <a:t>No cenário otimista, com 160 alunos no ano 1 e 1.100 ao final, alcançamos 1,83 milhão.</a:t>
             </a:r>
           </a:p>
           <a:p/>
           <a:p>
             <a:r>
-              <a:t>Na tabela, percorra a linha do tendencial, que está destacada: R$ 71 mil no ano um, R$ 284</a:t>
-            </a:r>
-          </a:p>
-          <a:p>
-            <a:r>
-              <a:t>mil no ano dois, R$ 744 mil no ano três. Se perguntarem por que a curva é tão inclinada, a</a:t>
-            </a:r>
-          </a:p>
-          <a:p>
-            <a:r>
-              <a:t>resposta tem duas partes que se somam: o número de alunos cresce, e a receita por viagem</a:t>
-            </a:r>
-          </a:p>
-          <a:p>
-            <a:r>
-              <a:t>também cresce, de R$ 157,60 para R$ 208,80, porque a comissão melhora.</a:t>
+              <a:t>As 5.508 viagens do cenário tendencial saem de multiplicar os alunos ativos de cada trimestre por 1,8 e somar os doze trimestres.</a:t>
             </a:r>
           </a:p>
           <a:p/>
           <a:p>
             <a:r>
-              <a:t>As 5.508 viagens da penúltima coluna saem de multiplicar os alunos ativos de cada trimestre</a:t>
-            </a:r>
-          </a:p>
-          <a:p>
-            <a:r>
-              <a:t>por 1,8 e somar os doze trimestres.</a:t>
-            </a:r>
-          </a:p>
-          <a:p/>
-          <a:p>
-            <a:r>
-              <a:t>E a última coluna é o melhor argumento de venda da apresentação inteira: R$ 1,95 milhão de</a:t>
-            </a:r>
-          </a:p>
-          <a:p>
-            <a:r>
-              <a:t>economia devolvida aos alunos, contra R$ 1,10 milhão de receita nossa. Devolvemos quase o</a:t>
-            </a:r>
-          </a:p>
-          <a:p>
-            <a:r>
-              <a:t>dobro do que ganhamos. Esse é o número que faz a escola querer indicar o serviço — não é</a:t>
-            </a:r>
-          </a:p>
-          <a:p>
-            <a:r>
-              <a:t>generosidade nossa, é aritmética do modelo, porque a maior parte da economia vem de comprar</a:t>
-            </a:r>
-          </a:p>
-          <a:p>
-            <a:r>
-              <a:t>na hora certa, não de margem que a gente abre mão.</a:t>
-            </a:r>
-          </a:p>
-          <a:p/>
-          <a:p>
-            <a:r>
-              <a:t>Se perguntarem de margem ou lucro, repita o recorte: esta sprint é de receita. E acrescente</a:t>
-            </a:r>
-          </a:p>
-          <a:p>
-            <a:r>
-              <a:t>uma coisa que costuma surpreender — não existe custo de mercadoria vendida aqui, porque nós</a:t>
-            </a:r>
-          </a:p>
-          <a:p>
-            <a:r>
-              <a:t>não compramos e revendemos passagem. O aluno paga o fornecedor direto. Todos os nossos</a:t>
-            </a:r>
-          </a:p>
-          <a:p>
-            <a:r>
-              <a:t>custos são operacionais, e eles entram na Sprint 5.</a:t>
+              <a:t>E há um número na última coluna que é o nosso melhor argumento: 1,95 milhão de reais devolvidos aos alunos em economia, contra 1,10 milhão de receita nossa. Nós devolvemos quase o dobro do que ganhamos. Isso não é generosidade, é aritmética do modelo — a maior parte da economia vem de comprar na hora certa, e não de margem que nós abrimos mão. É esse número que faz a escola querer indicar o serviço.</a:t>
             </a:r>
           </a:p>
         </p:txBody>

</xml_diff>